<commit_message>
Regenerate AI in Healthcare deck with Unsplash images (executive theme)
13 slides, 8-9 content slides with embedded Unsplash photos.

Co-Authored-By: Claude Sonnet 4.6 <noreply@anthropic.com>
</commit_message>
<xml_diff>
--- a/The Future of AI in Healthcare.pptx
+++ b/The Future of AI in Healthcare.pptx
@@ -18,6 +18,7 @@
     <p:sldId id="266" r:id="rId18"/>
     <p:sldId id="267" r:id="rId19"/>
     <p:sldId id="268" r:id="rId20"/>
+    <p:sldId id="269" r:id="rId21"/>
   </p:sldIdLst>
   <p:sldSz cx="9144000" cy="5143500" type="screen4x3"/>
   <p:notesSz cx="6858000" cy="9144000"/>
@@ -514,7 +515,7 @@
           <a:lstStyle/>
           <a:p>
             <a:r>
-              <a:t>Open with scale to capture executive attention. Source: Statista and Grand View Research projections. This sets the commercial and strategic context for the entire presentation.</a:t>
+              <a:t>Open with a striking market figure to establish urgency and scale. Source: Statista/Grand View Research estimates. This sets the tone that AI in healthcare is not speculative — it is an accelerating reality.</a:t>
             </a:r>
           </a:p>
         </p:txBody>
@@ -584,7 +585,7 @@
           <a:lstStyle/>
           <a:p>
             <a:r>
-              <a:t>Be direct about obstacles. Each bullet maps to a real barrier that has slowed enterprise adoption. Position these not as reasons to delay but as problems that demand strategic solutions.</a:t>
+              <a:t>Transition to the third section on governance, ethics, and adoption barriers. Essential for a balanced, credible executive presentation — acknowledge the hard problems.</a:t>
             </a:r>
           </a:p>
         </p:txBody>
@@ -654,7 +655,7 @@
           <a:lstStyle/>
           <a:p>
             <a:r>
-              <a:t>Use a credible clinical-academic voice to elevate the ethical argument. Topol is widely respected across clinical and technology audiences, lending authority to the governance imperative.</a:t>
+              <a:t>Four key risk categories: equity, privacy, regulation, and trust. Each requires dedicated strategy. This slide signals intellectual honesty and positions the presenter as a credible advisor, not a hype merchant.</a:t>
             </a:r>
           </a:p>
         </p:txBody>
@@ -724,7 +725,77 @@
           <a:lstStyle/>
           <a:p>
             <a:r>
-              <a:t>Close with actionable, prioritized next steps. This is the 'so what' slide that transforms insight into executive action. Each bullet is designed to be assignable to a specific C-suite owner.</a:t>
+              <a:t>Closing action slide. Five concrete, prioritized recommendations for C-suite and board-level leaders. Each is actionable and sequenced from foundational (data) to strategic (partnerships).</a:t>
+            </a:r>
+          </a:p>
+        </p:txBody>
+      </p:sp>
+      <p:sp>
+        <p:nvSpPr>
+          <p:cNvPr id="4" name="Slide Number Placeholder 3"/>
+          <p:cNvSpPr>
+            <a:spLocks noGrp="1"/>
+          </p:cNvSpPr>
+          <p:nvPr>
+            <p:ph type="sldNum" idx="5" sz="quarter"/>
+          </p:nvPr>
+        </p:nvSpPr>
+        <p:spPr/>
+      </p:sp>
+    </p:spTree>
+  </p:cSld>
+  <p:clrMapOvr>
+    <a:masterClrMapping/>
+  </p:clrMapOvr>
+</p:notes>
+</file>
+
+<file path=ppt/notesSlides/notesSlide13.xml><?xml version="1.0" encoding="utf-8"?>
+<p:notes xmlns:a="http://schemas.openxmlformats.org/drawingml/2006/main" xmlns:p="http://schemas.openxmlformats.org/presentationml/2006/main" xmlns:r="http://schemas.openxmlformats.org/officeDocument/2006/relationships">
+  <p:cSld>
+    <p:spTree>
+      <p:nvGrpSpPr>
+        <p:cNvPr id="1" name=""/>
+        <p:cNvGrpSpPr/>
+        <p:nvPr/>
+      </p:nvGrpSpPr>
+      <p:grpSpPr>
+        <a:xfrm>
+          <a:off x="0" y="0"/>
+          <a:ext cx="0" cy="0"/>
+          <a:chOff x="0" y="0"/>
+          <a:chExt cx="0" cy="0"/>
+        </a:xfrm>
+      </p:grpSpPr>
+      <p:sp>
+        <p:nvSpPr>
+          <p:cNvPr id="2" name="Slide Image Placeholder 1"/>
+          <p:cNvSpPr>
+            <a:spLocks noGrp="1"/>
+          </p:cNvSpPr>
+          <p:nvPr>
+            <p:ph type="sldImg" idx="2"/>
+          </p:nvPr>
+        </p:nvSpPr>
+        <p:spPr/>
+      </p:sp>
+      <p:sp>
+        <p:nvSpPr>
+          <p:cNvPr id="3" name="Notes Placeholder 2"/>
+          <p:cNvSpPr>
+            <a:spLocks noGrp="1"/>
+          </p:cNvSpPr>
+          <p:nvPr>
+            <p:ph type="body" idx="3" sz="quarter"/>
+          </p:nvPr>
+        </p:nvSpPr>
+        <p:spPr/>
+        <p:txBody>
+          <a:bodyPr/>
+          <a:lstStyle/>
+          <a:p>
+            <a:r>
+              <a:t>End with a forward-looking, decisive statement that serves as the presentation's core takeaway. Designed to inspire action while reinforcing the governance theme. Leave the audience with conviction, not just information.</a:t>
             </a:r>
           </a:p>
         </p:txBody>
@@ -794,7 +865,7 @@
           <a:lstStyle/>
           <a:p>
             <a:r>
-              <a:t>Provide a clear map of the presentation. Three major sections plus a forward-looking close. This helps the audience anchor expectations and track the narrative arc.</a:t>
+              <a:t>Agenda slide to frame the narrative arc. Three major sections: clinical applications, operational transformation, and risk/governance. This gives the audience a clear mental model for what follows.</a:t>
             </a:r>
           </a:p>
         </p:txBody>
@@ -864,7 +935,7 @@
           <a:lstStyle/>
           <a:p>
             <a:r>
-              <a:t>Transition into the first major theme — how AI is fundamentally reshaping clinical diagnosis and treatment personalization.</a:t>
+              <a:t>Transition into the first major section. This section covers why the current healthcare landscape demands AI — workforce shortages, diagnostic errors, and rising costs create a burning platform.</a:t>
             </a:r>
           </a:p>
         </p:txBody>
@@ -934,7 +1005,7 @@
           <a:lstStyle/>
           <a:p>
             <a:r>
-              <a:t>Highlight four proven high-impact use cases. Emphasize that these are not theoretical — they are deployed in leading health systems today. Reference studies from Mayo Clinic, Google Health, and Mount Sinai.</a:t>
+              <a:t>Establish the problem space with hard data. Each bullet represents a systemic failure that AI can meaningfully address. This builds the case that AI is not optional — it is necessary.</a:t>
             </a:r>
           </a:p>
         </p:txBody>
@@ -1004,7 +1075,7 @@
           <a:lstStyle/>
           <a:p>
             <a:r>
-              <a:t>Reinforce the diagnostic section with a concrete, peer-reviewed data point. Source: Nature Medicine, 2020 study by Google Health across US and UK datasets.</a:t>
+              <a:t>Shift from problem to solution. Showcase four high-impact clinical domains where AI is already delivering measurable results. Each bullet is grounded in emerging evidence from leading health systems and pharma.</a:t>
             </a:r>
           </a:p>
         </p:txBody>
@@ -1074,7 +1145,7 @@
           <a:lstStyle/>
           <a:p>
             <a:r>
-              <a:t>Shift the narrative from clinical applications to enterprise-wide operational gains — where CFOs and COOs see immediate ROI.</a:t>
+              <a:t>Use a thought-leader quote to humanize the narrative and counter the common fear that AI replaces clinicians. Topol is widely respected across clinical and executive audiences.</a:t>
             </a:r>
           </a:p>
         </p:txBody>
@@ -1144,7 +1215,7 @@
           <a:lstStyle/>
           <a:p>
             <a:r>
-              <a:t>Position AI as an operational lever, not just a clinical tool. These use cases resonate with non-clinical executives and board members focused on margin improvement and workforce challenges.</a:t>
+              <a:t>Transition to the second major section. Move from clinical applications to the business and operational side — where AI drives efficiency, reduces waste, and improves margins.</a:t>
             </a:r>
           </a:p>
         </p:txBody>
@@ -1214,7 +1285,7 @@
           <a:lstStyle/>
           <a:p>
             <a:r>
-              <a:t>Proactively address the number-one concern in any AI discussion — job displacement. Frame AI as a force multiplier for clinicians. Reference AMA physician sentiment surveys showing growing acceptance.</a:t>
+              <a:t>Demonstrate AI's breadth beyond clinical care. CFOs and COOs are key stakeholders — this slide speaks directly to margin improvement and operational resilience.</a:t>
             </a:r>
           </a:p>
         </p:txBody>
@@ -1284,7 +1355,7 @@
           <a:lstStyle/>
           <a:p>
             <a:r>
-              <a:t>Transition to the critical guardrails discussion. Credibility requires acknowledging challenges head-on rather than presenting an uncritical optimism narrative.</a:t>
+              <a:t>A single powerful number to punctuate the operational section. Source: Harvard Business Review / Accenture analysis. This anchors the business case before transitioning to risks.</a:t>
             </a:r>
           </a:p>
         </p:txBody>
@@ -4468,7 +4539,7 @@
     <p:bg>
       <p:bgPr>
         <a:solidFill>
-          <a:srgbClr val="B88600"/>
+          <a:srgbClr val="F5F4F0"/>
         </a:solidFill>
         <a:effectLst/>
       </p:bgPr>
@@ -4488,8 +4559,8 @@
         </p:nvSpPr>
         <p:spPr>
           <a:xfrm>
-            <a:off x="731520" y="1645920"/>
-            <a:ext cx="7680960" cy="1828800"/>
+            <a:off x="640080" y="228600"/>
+            <a:ext cx="7863840" cy="640080"/>
           </a:xfrm>
           <a:prstGeom prst="rect">
             <a:avLst/>
@@ -4502,15 +4573,128 @@
           </a:bodyPr>
           <a:lstStyle/>
           <a:p>
-            <a:pPr algn="l"/>
-            <a:r>
-              <a:rPr sz="3800" b="1">
+            <a:pPr algn="ctr"/>
+            <a:r>
+              <a:rPr sz="2200" b="1">
                 <a:solidFill>
-                  <a:srgbClr val="F5F4F0"/>
+                  <a:srgbClr val="55657A"/>
                 </a:solidFill>
                 <a:latin typeface="Calibri"/>
               </a:rPr>
-              <a:t>Section 3: Navigating Risk and Building Trust</a:t>
+              <a:t>The ROI Is Undeniable</a:t>
+            </a:r>
+          </a:p>
+        </p:txBody>
+      </p:sp>
+      <p:sp>
+        <p:nvSpPr>
+          <p:cNvPr id="3" name="Rectangle 2"/>
+          <p:cNvSpPr/>
+          <p:nvPr/>
+        </p:nvSpPr>
+        <p:spPr>
+          <a:xfrm>
+            <a:off x="3657600" y="960120"/>
+            <a:ext cx="1828800" cy="36576"/>
+          </a:xfrm>
+          <a:prstGeom prst="rect">
+            <a:avLst/>
+          </a:prstGeom>
+          <a:solidFill>
+            <a:srgbClr val="B88600"/>
+          </a:solidFill>
+          <a:ln>
+            <a:noFill/>
+          </a:ln>
+        </p:spPr>
+        <p:style>
+          <a:lnRef idx="1">
+            <a:schemeClr val="accent1"/>
+          </a:lnRef>
+          <a:fillRef idx="3">
+            <a:schemeClr val="accent1"/>
+          </a:fillRef>
+          <a:effectRef idx="2">
+            <a:schemeClr val="accent1"/>
+          </a:effectRef>
+          <a:fontRef idx="minor">
+            <a:schemeClr val="lt1"/>
+          </a:fontRef>
+        </p:style>
+        <p:txBody>
+          <a:bodyPr rtlCol="0" anchor="ctr"/>
+          <a:lstStyle/>
+          <a:p>
+            <a:pPr algn="ctr"/>
+          </a:p>
+        </p:txBody>
+      </p:sp>
+      <p:sp>
+        <p:nvSpPr>
+          <p:cNvPr id="4" name="TextBox 3"/>
+          <p:cNvSpPr txBox="1"/>
+          <p:nvPr/>
+        </p:nvSpPr>
+        <p:spPr>
+          <a:xfrm>
+            <a:off x="457200" y="1097280"/>
+            <a:ext cx="8229600" cy="2194560"/>
+          </a:xfrm>
+          <a:prstGeom prst="rect">
+            <a:avLst/>
+          </a:prstGeom>
+          <a:noFill/>
+        </p:spPr>
+        <p:txBody>
+          <a:bodyPr wrap="square">
+            <a:spAutoFit/>
+          </a:bodyPr>
+          <a:lstStyle/>
+          <a:p>
+            <a:pPr algn="ctr"/>
+            <a:r>
+              <a:rPr sz="8000" b="1">
+                <a:solidFill>
+                  <a:srgbClr val="B88600"/>
+                </a:solidFill>
+                <a:latin typeface="Calibri"/>
+              </a:rPr>
+              <a:t>$360B</a:t>
+            </a:r>
+          </a:p>
+        </p:txBody>
+      </p:sp>
+      <p:sp>
+        <p:nvSpPr>
+          <p:cNvPr id="5" name="TextBox 4"/>
+          <p:cNvSpPr txBox="1"/>
+          <p:nvPr/>
+        </p:nvSpPr>
+        <p:spPr>
+          <a:xfrm>
+            <a:off x="457200" y="3383280"/>
+            <a:ext cx="8229600" cy="731520"/>
+          </a:xfrm>
+          <a:prstGeom prst="rect">
+            <a:avLst/>
+          </a:prstGeom>
+          <a:noFill/>
+        </p:spPr>
+        <p:txBody>
+          <a:bodyPr wrap="square">
+            <a:spAutoFit/>
+          </a:bodyPr>
+          <a:lstStyle/>
+          <a:p>
+            <a:pPr algn="ctr"/>
+            <a:r>
+              <a:rPr sz="2000" b="0">
+                <a:solidFill>
+                  <a:srgbClr val="0D1B2A"/>
+                </a:solidFill>
+                <a:latin typeface="Calibri"/>
+              </a:rPr>
+              <a:t>Estimated annual savings potential from AI adoption across U.S. healthcare</a:t>
             </a:r>
           </a:p>
         </p:txBody>
@@ -4529,7 +4713,7 @@
     <p:bg>
       <p:bgPr>
         <a:solidFill>
-          <a:srgbClr val="F5F4F0"/>
+          <a:srgbClr val="B88600"/>
         </a:solidFill>
         <a:effectLst/>
       </p:bgPr>
@@ -4543,57 +4727,14 @@
       <p:grpSpPr/>
       <p:sp>
         <p:nvSpPr>
-          <p:cNvPr id="2" name="Rectangle 1"/>
-          <p:cNvSpPr/>
-          <p:nvPr/>
-        </p:nvSpPr>
-        <p:spPr>
-          <a:xfrm>
-            <a:off x="457200" y="1005840"/>
-            <a:ext cx="54864" cy="502920"/>
-          </a:xfrm>
-          <a:prstGeom prst="rect">
-            <a:avLst/>
-          </a:prstGeom>
-          <a:solidFill>
-            <a:srgbClr val="B88600"/>
-          </a:solidFill>
-          <a:ln>
-            <a:noFill/>
-          </a:ln>
-        </p:spPr>
-        <p:style>
-          <a:lnRef idx="1">
-            <a:schemeClr val="accent1"/>
-          </a:lnRef>
-          <a:fillRef idx="3">
-            <a:schemeClr val="accent1"/>
-          </a:fillRef>
-          <a:effectRef idx="2">
-            <a:schemeClr val="accent1"/>
-          </a:effectRef>
-          <a:fontRef idx="minor">
-            <a:schemeClr val="lt1"/>
-          </a:fontRef>
-        </p:style>
-        <p:txBody>
-          <a:bodyPr rtlCol="0" anchor="ctr"/>
-          <a:lstStyle/>
-          <a:p>
-            <a:pPr algn="ctr"/>
-          </a:p>
-        </p:txBody>
-      </p:sp>
-      <p:sp>
-        <p:nvSpPr>
-          <p:cNvPr id="3" name="TextBox 2"/>
+          <p:cNvPr id="2" name="TextBox 1"/>
           <p:cNvSpPr txBox="1"/>
           <p:nvPr/>
         </p:nvSpPr>
         <p:spPr>
           <a:xfrm>
-            <a:off x="640080" y="256032"/>
-            <a:ext cx="8046720" cy="822960"/>
+            <a:off x="731520" y="1645920"/>
+            <a:ext cx="7680960" cy="1828800"/>
           </a:xfrm>
           <a:prstGeom prst="rect">
             <a:avLst/>
@@ -4608,155 +4749,13 @@
           <a:p>
             <a:pPr algn="l"/>
             <a:r>
-              <a:rPr sz="2800" b="1">
+              <a:rPr sz="3800" b="1">
                 <a:solidFill>
-                  <a:srgbClr val="0D1B2A"/>
+                  <a:srgbClr val="F5F4F0"/>
                 </a:solidFill>
                 <a:latin typeface="Calibri"/>
               </a:rPr>
-              <a:t>The Critical Barriers to Scaled Adoption</a:t>
-            </a:r>
-          </a:p>
-        </p:txBody>
-      </p:sp>
-      <p:sp>
-        <p:nvSpPr>
-          <p:cNvPr id="4" name="Rectangle 3"/>
-          <p:cNvSpPr/>
-          <p:nvPr/>
-        </p:nvSpPr>
-        <p:spPr>
-          <a:xfrm>
-            <a:off x="457200" y="1024128"/>
-            <a:ext cx="8229600" cy="18288"/>
-          </a:xfrm>
-          <a:prstGeom prst="rect">
-            <a:avLst/>
-          </a:prstGeom>
-          <a:solidFill>
-            <a:srgbClr val="E2DED5"/>
-          </a:solidFill>
-          <a:ln>
-            <a:noFill/>
-          </a:ln>
-        </p:spPr>
-        <p:style>
-          <a:lnRef idx="1">
-            <a:schemeClr val="accent1"/>
-          </a:lnRef>
-          <a:fillRef idx="3">
-            <a:schemeClr val="accent1"/>
-          </a:fillRef>
-          <a:effectRef idx="2">
-            <a:schemeClr val="accent1"/>
-          </a:effectRef>
-          <a:fontRef idx="minor">
-            <a:schemeClr val="lt1"/>
-          </a:fontRef>
-        </p:style>
-        <p:txBody>
-          <a:bodyPr rtlCol="0" anchor="ctr"/>
-          <a:lstStyle/>
-          <a:p>
-            <a:pPr algn="ctr"/>
-          </a:p>
-        </p:txBody>
-      </p:sp>
-      <p:sp>
-        <p:nvSpPr>
-          <p:cNvPr id="5" name="TextBox 4"/>
-          <p:cNvSpPr txBox="1"/>
-          <p:nvPr/>
-        </p:nvSpPr>
-        <p:spPr>
-          <a:xfrm>
-            <a:off x="640080" y="1234440"/>
-            <a:ext cx="8046720" cy="3657600"/>
-          </a:xfrm>
-          <a:prstGeom prst="rect">
-            <a:avLst/>
-          </a:prstGeom>
-          <a:noFill/>
-        </p:spPr>
-        <p:txBody>
-          <a:bodyPr wrap="square">
-            <a:spAutoFit/>
-          </a:bodyPr>
-          <a:lstStyle/>
-          <a:p>
-            <a:pPr>
-              <a:spcBef>
-                <a:spcPts val="1000"/>
-              </a:spcBef>
-            </a:pPr>
-            <a:r>
-              <a:rPr sz="1900">
-                <a:solidFill>
-                  <a:srgbClr val="0D1B2A"/>
-                </a:solidFill>
-                <a:latin typeface="Calibri"/>
-              </a:rPr>
-              <a:t>  Algorithmic bias risks widening existing health disparities</a:t>
-            </a:r>
-            <a:r>
-              <a:t/>
-            </a:r>
-          </a:p>
-          <a:p>
-            <a:pPr>
-              <a:spcBef>
-                <a:spcPts val="1000"/>
-              </a:spcBef>
-            </a:pPr>
-            <a:r>
-              <a:rPr sz="1900">
-                <a:solidFill>
-                  <a:srgbClr val="0D1B2A"/>
-                </a:solidFill>
-                <a:latin typeface="Calibri"/>
-              </a:rPr>
-              <a:t>  Regulatory frameworks lag behind the pace of innovation</a:t>
-            </a:r>
-            <a:r>
-              <a:t/>
-            </a:r>
-          </a:p>
-          <a:p>
-            <a:pPr>
-              <a:spcBef>
-                <a:spcPts val="1000"/>
-              </a:spcBef>
-            </a:pPr>
-            <a:r>
-              <a:rPr sz="1900">
-                <a:solidFill>
-                  <a:srgbClr val="0D1B2A"/>
-                </a:solidFill>
-                <a:latin typeface="Calibri"/>
-              </a:rPr>
-              <a:t>  Data privacy concerns limit cross-institutional collaboration</a:t>
-            </a:r>
-            <a:r>
-              <a:t/>
-            </a:r>
-          </a:p>
-          <a:p>
-            <a:pPr>
-              <a:spcBef>
-                <a:spcPts val="1000"/>
-              </a:spcBef>
-            </a:pPr>
-            <a:r>
-              <a:rPr sz="1900">
-                <a:solidFill>
-                  <a:srgbClr val="0D1B2A"/>
-                </a:solidFill>
-                <a:latin typeface="Calibri"/>
-              </a:rPr>
-              <a:t>  Black-box models erode clinician and patient trust</a:t>
-            </a:r>
-            <a:r>
-              <a:t/>
+              <a:t>Navigating Risk and Building Trust</a:t>
             </a:r>
           </a:p>
         </p:txBody>
@@ -4789,119 +4788,14 @@
       <p:grpSpPr/>
       <p:sp>
         <p:nvSpPr>
-          <p:cNvPr id="2" name="TextBox 1"/>
-          <p:cNvSpPr txBox="1"/>
-          <p:nvPr/>
-        </p:nvSpPr>
-        <p:spPr>
-          <a:xfrm>
-            <a:off x="365760" y="91440"/>
-            <a:ext cx="1371600" cy="1097280"/>
-          </a:xfrm>
-          <a:prstGeom prst="rect">
-            <a:avLst/>
-          </a:prstGeom>
-          <a:noFill/>
-        </p:spPr>
-        <p:txBody>
-          <a:bodyPr wrap="square">
-            <a:spAutoFit/>
-          </a:bodyPr>
-          <a:lstStyle/>
-          <a:p>
-            <a:pPr algn="l"/>
-            <a:r>
-              <a:rPr sz="7200" b="1">
-                <a:solidFill>
-                  <a:srgbClr val="B88600"/>
-                </a:solidFill>
-                <a:latin typeface="Calibri"/>
-              </a:rPr>
-              <a:t>“</a:t>
-            </a:r>
-          </a:p>
-        </p:txBody>
-      </p:sp>
-      <p:sp>
-        <p:nvSpPr>
-          <p:cNvPr id="3" name="TextBox 2"/>
-          <p:cNvSpPr txBox="1"/>
-          <p:nvPr/>
-        </p:nvSpPr>
-        <p:spPr>
-          <a:xfrm>
-            <a:off x="640080" y="914400"/>
-            <a:ext cx="7863840" cy="2560320"/>
-          </a:xfrm>
-          <a:prstGeom prst="rect">
-            <a:avLst/>
-          </a:prstGeom>
-          <a:noFill/>
-        </p:spPr>
-        <p:txBody>
-          <a:bodyPr wrap="square">
-            <a:spAutoFit/>
-          </a:bodyPr>
-          <a:lstStyle/>
-          <a:p>
-            <a:pPr algn="l"/>
-            <a:r>
-              <a:rPr sz="2200" b="0">
-                <a:solidFill>
-                  <a:srgbClr val="0D1B2A"/>
-                </a:solidFill>
-                <a:latin typeface="Calibri"/>
-              </a:rPr>
-              <a:t>The question is not whether AI will transform healthcare — it is whether we will govern it wisely enough to ensure it transforms healthcare equitably.</a:t>
-            </a:r>
-          </a:p>
-        </p:txBody>
-      </p:sp>
-      <p:sp>
-        <p:nvSpPr>
-          <p:cNvPr id="4" name="TextBox 3"/>
-          <p:cNvSpPr txBox="1"/>
-          <p:nvPr/>
-        </p:nvSpPr>
-        <p:spPr>
-          <a:xfrm>
-            <a:off x="640080" y="3657600"/>
-            <a:ext cx="7863840" cy="457200"/>
-          </a:xfrm>
-          <a:prstGeom prst="rect">
-            <a:avLst/>
-          </a:prstGeom>
-          <a:noFill/>
-        </p:spPr>
-        <p:txBody>
-          <a:bodyPr wrap="square">
-            <a:spAutoFit/>
-          </a:bodyPr>
-          <a:lstStyle/>
-          <a:p>
-            <a:pPr algn="l"/>
-            <a:r>
-              <a:rPr sz="1600" b="0">
-                <a:solidFill>
-                  <a:srgbClr val="55657A"/>
-                </a:solidFill>
-                <a:latin typeface="Calibri"/>
-              </a:rPr>
-              <a:t>— Dr. Eric Topol, Scripps Research</a:t>
-            </a:r>
-          </a:p>
-        </p:txBody>
-      </p:sp>
-      <p:sp>
-        <p:nvSpPr>
-          <p:cNvPr id="5" name="Rectangle 4"/>
+          <p:cNvPr id="2" name="Rectangle 1"/>
           <p:cNvSpPr/>
           <p:nvPr/>
         </p:nvSpPr>
         <p:spPr>
           <a:xfrm>
-            <a:off x="640080" y="4297680"/>
-            <a:ext cx="1828800" cy="36576"/>
+            <a:off x="457200" y="1005840"/>
+            <a:ext cx="54864" cy="502920"/>
           </a:xfrm>
           <a:prstGeom prst="rect">
             <a:avLst/>
@@ -4935,6 +4829,195 @@
           </a:p>
         </p:txBody>
       </p:sp>
+      <p:sp>
+        <p:nvSpPr>
+          <p:cNvPr id="3" name="TextBox 2"/>
+          <p:cNvSpPr txBox="1"/>
+          <p:nvPr/>
+        </p:nvSpPr>
+        <p:spPr>
+          <a:xfrm>
+            <a:off x="640080" y="256032"/>
+            <a:ext cx="5029200" cy="822960"/>
+          </a:xfrm>
+          <a:prstGeom prst="rect">
+            <a:avLst/>
+          </a:prstGeom>
+          <a:noFill/>
+        </p:spPr>
+        <p:txBody>
+          <a:bodyPr wrap="square">
+            <a:spAutoFit/>
+          </a:bodyPr>
+          <a:lstStyle/>
+          <a:p>
+            <a:pPr algn="l"/>
+            <a:r>
+              <a:rPr sz="2800" b="1">
+                <a:solidFill>
+                  <a:srgbClr val="0D1B2A"/>
+                </a:solidFill>
+                <a:latin typeface="Calibri"/>
+              </a:rPr>
+              <a:t>Critical Challenges to Address</a:t>
+            </a:r>
+          </a:p>
+        </p:txBody>
+      </p:sp>
+      <p:sp>
+        <p:nvSpPr>
+          <p:cNvPr id="4" name="Rectangle 3"/>
+          <p:cNvSpPr/>
+          <p:nvPr/>
+        </p:nvSpPr>
+        <p:spPr>
+          <a:xfrm>
+            <a:off x="457200" y="1024128"/>
+            <a:ext cx="5212080" cy="18288"/>
+          </a:xfrm>
+          <a:prstGeom prst="rect">
+            <a:avLst/>
+          </a:prstGeom>
+          <a:solidFill>
+            <a:srgbClr val="E2DED5"/>
+          </a:solidFill>
+          <a:ln>
+            <a:noFill/>
+          </a:ln>
+        </p:spPr>
+        <p:style>
+          <a:lnRef idx="1">
+            <a:schemeClr val="accent1"/>
+          </a:lnRef>
+          <a:fillRef idx="3">
+            <a:schemeClr val="accent1"/>
+          </a:fillRef>
+          <a:effectRef idx="2">
+            <a:schemeClr val="accent1"/>
+          </a:effectRef>
+          <a:fontRef idx="minor">
+            <a:schemeClr val="lt1"/>
+          </a:fontRef>
+        </p:style>
+        <p:txBody>
+          <a:bodyPr rtlCol="0" anchor="ctr"/>
+          <a:lstStyle/>
+          <a:p>
+            <a:pPr algn="ctr"/>
+          </a:p>
+        </p:txBody>
+      </p:sp>
+      <p:sp>
+        <p:nvSpPr>
+          <p:cNvPr id="5" name="TextBox 4"/>
+          <p:cNvSpPr txBox="1"/>
+          <p:nvPr/>
+        </p:nvSpPr>
+        <p:spPr>
+          <a:xfrm>
+            <a:off x="640080" y="1234440"/>
+            <a:ext cx="5029200" cy="3657600"/>
+          </a:xfrm>
+          <a:prstGeom prst="rect">
+            <a:avLst/>
+          </a:prstGeom>
+          <a:noFill/>
+        </p:spPr>
+        <p:txBody>
+          <a:bodyPr wrap="square">
+            <a:spAutoFit/>
+          </a:bodyPr>
+          <a:lstStyle/>
+          <a:p>
+            <a:pPr>
+              <a:spcBef>
+                <a:spcPts val="1000"/>
+              </a:spcBef>
+            </a:pPr>
+            <a:r>
+              <a:rPr sz="1900">
+                <a:solidFill>
+                  <a:srgbClr val="0D1B2A"/>
+                </a:solidFill>
+                <a:latin typeface="Calibri"/>
+              </a:rPr>
+              <a:t>  Algorithmic bias risks widening health disparities</a:t>
+            </a:r>
+          </a:p>
+          <a:p>
+            <a:pPr>
+              <a:spcBef>
+                <a:spcPts val="1000"/>
+              </a:spcBef>
+            </a:pPr>
+            <a:r>
+              <a:rPr sz="1900">
+                <a:solidFill>
+                  <a:srgbClr val="0D1B2A"/>
+                </a:solidFill>
+                <a:latin typeface="Calibri"/>
+              </a:rPr>
+              <a:t>  Data privacy regulations vary widely across jurisdictions</a:t>
+            </a:r>
+          </a:p>
+          <a:p>
+            <a:pPr>
+              <a:spcBef>
+                <a:spcPts val="1000"/>
+              </a:spcBef>
+            </a:pPr>
+            <a:r>
+              <a:rPr sz="1900">
+                <a:solidFill>
+                  <a:srgbClr val="0D1B2A"/>
+                </a:solidFill>
+                <a:latin typeface="Calibri"/>
+              </a:rPr>
+              <a:t>  FDA approval frameworks lag behind AI innovation speed</a:t>
+            </a:r>
+          </a:p>
+          <a:p>
+            <a:pPr>
+              <a:spcBef>
+                <a:spcPts val="1000"/>
+              </a:spcBef>
+            </a:pPr>
+            <a:r>
+              <a:rPr sz="1900">
+                <a:solidFill>
+                  <a:srgbClr val="0D1B2A"/>
+                </a:solidFill>
+                <a:latin typeface="Calibri"/>
+              </a:rPr>
+              <a:t>  Clinician trust remains the ultimate adoption bottleneck</a:t>
+            </a:r>
+          </a:p>
+        </p:txBody>
+      </p:sp>
+      <p:pic>
+        <p:nvPicPr>
+          <p:cNvPr id="6" name="Picture 5" descr="image.jpg"/>
+          <p:cNvPicPr>
+            <a:picLocks noChangeAspect="1"/>
+          </p:cNvPicPr>
+          <p:nvPr/>
+        </p:nvPicPr>
+        <p:blipFill>
+          <a:blip r:embed="rId2"/>
+          <a:stretch>
+            <a:fillRect/>
+          </a:stretch>
+        </p:blipFill>
+        <p:spPr>
+          <a:xfrm>
+            <a:off x="5852160" y="1097280"/>
+            <a:ext cx="2926080" cy="3474720"/>
+          </a:xfrm>
+          <a:prstGeom prst="rect">
+            <a:avLst/>
+          </a:prstGeom>
+        </p:spPr>
+      </p:pic>
     </p:spTree>
   </p:cSld>
   <p:clrMapOvr>
@@ -5013,7 +5096,7 @@
         <p:spPr>
           <a:xfrm>
             <a:off x="640080" y="256032"/>
-            <a:ext cx="8046720" cy="822960"/>
+            <a:ext cx="5029200" cy="822960"/>
           </a:xfrm>
           <a:prstGeom prst="rect">
             <a:avLst/>
@@ -5034,7 +5117,7 @@
                 </a:solidFill>
                 <a:latin typeface="Calibri"/>
               </a:rPr>
-              <a:t>A Strategic Roadmap for Leaders</a:t>
+              <a:t>Strategic Imperatives for Leaders</a:t>
             </a:r>
           </a:p>
         </p:txBody>
@@ -5048,7 +5131,7 @@
         <p:spPr>
           <a:xfrm>
             <a:off x="457200" y="1024128"/>
-            <a:ext cx="8229600" cy="18288"/>
+            <a:ext cx="5212080" cy="18288"/>
           </a:xfrm>
           <a:prstGeom prst="rect">
             <a:avLst/>
@@ -5091,7 +5174,7 @@
         <p:spPr>
           <a:xfrm>
             <a:off x="640080" y="1234440"/>
-            <a:ext cx="8046720" cy="3657600"/>
+            <a:ext cx="5029200" cy="3657600"/>
           </a:xfrm>
           <a:prstGeom prst="rect">
             <a:avLst/>
@@ -5116,10 +5199,7 @@
                 </a:solidFill>
                 <a:latin typeface="Calibri"/>
               </a:rPr>
-              <a:t>  Invest in curated, interoperable data infrastructure now</a:t>
-            </a:r>
-            <a:r>
-              <a:t/>
+              <a:t>  Invest in AI-ready data infrastructure now</a:t>
             </a:r>
           </a:p>
           <a:p>
@@ -5135,10 +5215,7 @@
                 </a:solidFill>
                 <a:latin typeface="Calibri"/>
               </a:rPr>
-              <a:t>  Establish AI governance boards with clinical representation</a:t>
-            </a:r>
-            <a:r>
-              <a:t/>
+              <a:t>  Establish cross-functional AI governance boards</a:t>
             </a:r>
           </a:p>
           <a:p>
@@ -5154,10 +5231,7 @@
                 </a:solidFill>
                 <a:latin typeface="Calibri"/>
               </a:rPr>
-              <a:t>  Launch pilot programs with measurable 90-day outcome targets</a:t>
-            </a:r>
-            <a:r>
-              <a:t/>
+              <a:t>  Pilot narrow use cases with measurable clinical KPIs</a:t>
             </a:r>
           </a:p>
           <a:p>
@@ -5173,10 +5247,7 @@
                 </a:solidFill>
                 <a:latin typeface="Calibri"/>
               </a:rPr>
-              <a:t>  Build strategic partnerships across payers, providers, and tech</a:t>
-            </a:r>
-            <a:r>
-              <a:t/>
+              <a:t>  Build clinician champions through co-design models</a:t>
             </a:r>
           </a:p>
           <a:p>
@@ -5192,11 +5263,206 @@
                 </a:solidFill>
                 <a:latin typeface="Calibri"/>
               </a:rPr>
-              <a:t>  Champion transparency to earn patient and regulator trust</a:t>
-            </a:r>
-            <a:r>
-              <a:t/>
-            </a:r>
+              <a:t>  Partner across ecosystem — payers, regulators, startups</a:t>
+            </a:r>
+          </a:p>
+        </p:txBody>
+      </p:sp>
+      <p:pic>
+        <p:nvPicPr>
+          <p:cNvPr id="6" name="Picture 5" descr="image.jpg"/>
+          <p:cNvPicPr>
+            <a:picLocks noChangeAspect="1"/>
+          </p:cNvPicPr>
+          <p:nvPr/>
+        </p:nvPicPr>
+        <p:blipFill>
+          <a:blip r:embed="rId2"/>
+          <a:stretch>
+            <a:fillRect/>
+          </a:stretch>
+        </p:blipFill>
+        <p:spPr>
+          <a:xfrm>
+            <a:off x="5852160" y="1097280"/>
+            <a:ext cx="2926080" cy="3474720"/>
+          </a:xfrm>
+          <a:prstGeom prst="rect">
+            <a:avLst/>
+          </a:prstGeom>
+        </p:spPr>
+      </p:pic>
+    </p:spTree>
+  </p:cSld>
+  <p:clrMapOvr>
+    <a:masterClrMapping/>
+  </p:clrMapOvr>
+</p:sld>
+</file>
+
+<file path=ppt/slides/slide14.xml><?xml version="1.0" encoding="utf-8"?>
+<p:sld xmlns:a="http://schemas.openxmlformats.org/drawingml/2006/main" xmlns:p="http://schemas.openxmlformats.org/presentationml/2006/main" xmlns:r="http://schemas.openxmlformats.org/officeDocument/2006/relationships">
+  <p:cSld>
+    <p:bg>
+      <p:bgPr>
+        <a:solidFill>
+          <a:srgbClr val="F5F4F0"/>
+        </a:solidFill>
+        <a:effectLst/>
+      </p:bgPr>
+    </p:bg>
+    <p:spTree>
+      <p:nvGrpSpPr>
+        <p:cNvPr id="1" name=""/>
+        <p:cNvGrpSpPr/>
+        <p:nvPr/>
+      </p:nvGrpSpPr>
+      <p:grpSpPr/>
+      <p:sp>
+        <p:nvSpPr>
+          <p:cNvPr id="2" name="TextBox 1"/>
+          <p:cNvSpPr txBox="1"/>
+          <p:nvPr/>
+        </p:nvSpPr>
+        <p:spPr>
+          <a:xfrm>
+            <a:off x="365760" y="91440"/>
+            <a:ext cx="1371600" cy="1097280"/>
+          </a:xfrm>
+          <a:prstGeom prst="rect">
+            <a:avLst/>
+          </a:prstGeom>
+          <a:noFill/>
+        </p:spPr>
+        <p:txBody>
+          <a:bodyPr wrap="square">
+            <a:spAutoFit/>
+          </a:bodyPr>
+          <a:lstStyle/>
+          <a:p>
+            <a:pPr algn="l"/>
+            <a:r>
+              <a:rPr sz="7200" b="1">
+                <a:solidFill>
+                  <a:srgbClr val="B88600"/>
+                </a:solidFill>
+                <a:latin typeface="Calibri"/>
+              </a:rPr>
+              <a:t>“</a:t>
+            </a:r>
+          </a:p>
+        </p:txBody>
+      </p:sp>
+      <p:sp>
+        <p:nvSpPr>
+          <p:cNvPr id="3" name="TextBox 2"/>
+          <p:cNvSpPr txBox="1"/>
+          <p:nvPr/>
+        </p:nvSpPr>
+        <p:spPr>
+          <a:xfrm>
+            <a:off x="640080" y="914400"/>
+            <a:ext cx="7863840" cy="2560320"/>
+          </a:xfrm>
+          <a:prstGeom prst="rect">
+            <a:avLst/>
+          </a:prstGeom>
+          <a:noFill/>
+        </p:spPr>
+        <p:txBody>
+          <a:bodyPr wrap="square">
+            <a:spAutoFit/>
+          </a:bodyPr>
+          <a:lstStyle/>
+          <a:p>
+            <a:pPr algn="l"/>
+            <a:r>
+              <a:rPr sz="2200" b="0">
+                <a:solidFill>
+                  <a:srgbClr val="0D1B2A"/>
+                </a:solidFill>
+                <a:latin typeface="Calibri"/>
+              </a:rPr>
+              <a:t>In ten years, the organizations that thrived will not be those that feared AI — but those that governed it wisely and deployed it boldly.</a:t>
+            </a:r>
+          </a:p>
+        </p:txBody>
+      </p:sp>
+      <p:sp>
+        <p:nvSpPr>
+          <p:cNvPr id="4" name="TextBox 3"/>
+          <p:cNvSpPr txBox="1"/>
+          <p:nvPr/>
+        </p:nvSpPr>
+        <p:spPr>
+          <a:xfrm>
+            <a:off x="640080" y="3657600"/>
+            <a:ext cx="7863840" cy="457200"/>
+          </a:xfrm>
+          <a:prstGeom prst="rect">
+            <a:avLst/>
+          </a:prstGeom>
+          <a:noFill/>
+        </p:spPr>
+        <p:txBody>
+          <a:bodyPr wrap="square">
+            <a:spAutoFit/>
+          </a:bodyPr>
+          <a:lstStyle/>
+          <a:p>
+            <a:pPr algn="l"/>
+            <a:r>
+              <a:rPr sz="1600" b="0">
+                <a:solidFill>
+                  <a:srgbClr val="55657A"/>
+                </a:solidFill>
+                <a:latin typeface="Calibri"/>
+              </a:rPr>
+              <a:t>— Presentation Closing Thesis</a:t>
+            </a:r>
+          </a:p>
+        </p:txBody>
+      </p:sp>
+      <p:sp>
+        <p:nvSpPr>
+          <p:cNvPr id="5" name="Rectangle 4"/>
+          <p:cNvSpPr/>
+          <p:nvPr/>
+        </p:nvSpPr>
+        <p:spPr>
+          <a:xfrm>
+            <a:off x="640080" y="4297680"/>
+            <a:ext cx="1828800" cy="36576"/>
+          </a:xfrm>
+          <a:prstGeom prst="rect">
+            <a:avLst/>
+          </a:prstGeom>
+          <a:solidFill>
+            <a:srgbClr val="B88600"/>
+          </a:solidFill>
+          <a:ln>
+            <a:noFill/>
+          </a:ln>
+        </p:spPr>
+        <p:style>
+          <a:lnRef idx="1">
+            <a:schemeClr val="accent1"/>
+          </a:lnRef>
+          <a:fillRef idx="3">
+            <a:schemeClr val="accent1"/>
+          </a:fillRef>
+          <a:effectRef idx="2">
+            <a:schemeClr val="accent1"/>
+          </a:effectRef>
+          <a:fontRef idx="minor">
+            <a:schemeClr val="lt1"/>
+          </a:fontRef>
+        </p:style>
+        <p:txBody>
+          <a:bodyPr rtlCol="0" anchor="ctr"/>
+          <a:lstStyle/>
+          <a:p>
+            <a:pPr algn="ctr"/>
           </a:p>
         </p:txBody>
       </p:sp>
@@ -5256,7 +5522,7 @@
                 </a:solidFill>
                 <a:latin typeface="Calibri"/>
               </a:rPr>
-              <a:t>The Opportunity Before Us</a:t>
+              <a:t>The AI Healthcare Revolution Is Here</a:t>
             </a:r>
           </a:p>
         </p:txBody>
@@ -5369,7 +5635,7 @@
                 </a:solidFill>
                 <a:latin typeface="Calibri"/>
               </a:rPr>
-              <a:t>Projected AI in healthcare market size by 2030 — a 10x increase from 2023</a:t>
+              <a:t>Projected global AI in healthcare market size by 2030 — a 10x increase from 2023</a:t>
             </a:r>
           </a:p>
         </p:txBody>
@@ -5473,7 +5739,7 @@
                 </a:solidFill>
                 <a:latin typeface="Calibri"/>
               </a:rPr>
-              <a:t>Today's Agenda</a:t>
+              <a:t>What We'll Cover Today</a:t>
             </a:r>
           </a:p>
         </p:txBody>
@@ -5555,10 +5821,7 @@
                 </a:solidFill>
                 <a:latin typeface="Calibri"/>
               </a:rPr>
-              <a:t>  The diagnostic revolution: AI-powered precision medicine</a:t>
-            </a:r>
-            <a:r>
-              <a:t/>
+              <a:t>  The clinical imperative: why healthcare needs AI now</a:t>
             </a:r>
           </a:p>
           <a:p>
@@ -5574,10 +5837,23 @@
                 </a:solidFill>
                 <a:latin typeface="Calibri"/>
               </a:rPr>
-              <a:t>  Operational transformation: from back office to bedside</a:t>
-            </a:r>
-            <a:r>
-              <a:t/>
+              <a:t>  Diagnostic and therapeutic breakthroughs reshaping care</a:t>
+            </a:r>
+          </a:p>
+          <a:p>
+            <a:pPr>
+              <a:spcBef>
+                <a:spcPts val="1000"/>
+              </a:spcBef>
+            </a:pPr>
+            <a:r>
+              <a:rPr sz="1900">
+                <a:solidFill>
+                  <a:srgbClr val="0D1B2A"/>
+                </a:solidFill>
+                <a:latin typeface="Calibri"/>
+              </a:rPr>
+              <a:t>  Operational transformation across the value chain</a:t>
             </a:r>
           </a:p>
           <a:p>
@@ -5595,9 +5871,6 @@
               </a:rPr>
               <a:t>  Navigating risks: ethics, regulation, and trust</a:t>
             </a:r>
-            <a:r>
-              <a:t/>
-            </a:r>
           </a:p>
           <a:p>
             <a:pPr>
@@ -5612,10 +5885,7 @@
                 </a:solidFill>
                 <a:latin typeface="Calibri"/>
               </a:rPr>
-              <a:t>  A strategic roadmap for healthcare leaders</a:t>
-            </a:r>
-            <a:r>
-              <a:t/>
+              <a:t>  Strategic roadmap for health system leaders</a:t>
             </a:r>
           </a:p>
         </p:txBody>
@@ -5676,7 +5946,7 @@
                 </a:solidFill>
                 <a:latin typeface="Calibri"/>
               </a:rPr>
-              <a:t>Section 1: The Diagnostic Revolution</a:t>
+              <a:t>The Clinical Imperative</a:t>
             </a:r>
           </a:p>
         </p:txBody>
@@ -5759,7 +6029,7 @@
         <p:spPr>
           <a:xfrm>
             <a:off x="640080" y="256032"/>
-            <a:ext cx="8046720" cy="822960"/>
+            <a:ext cx="5029200" cy="822960"/>
           </a:xfrm>
           <a:prstGeom prst="rect">
             <a:avLst/>
@@ -5780,7 +6050,7 @@
                 </a:solidFill>
                 <a:latin typeface="Calibri"/>
               </a:rPr>
-              <a:t>AI Is Redefining Clinical Accuracy</a:t>
+              <a:t>Healthcare Is at a Breaking Point</a:t>
             </a:r>
           </a:p>
         </p:txBody>
@@ -5794,7 +6064,7 @@
         <p:spPr>
           <a:xfrm>
             <a:off x="457200" y="1024128"/>
-            <a:ext cx="8229600" cy="18288"/>
+            <a:ext cx="5212080" cy="18288"/>
           </a:xfrm>
           <a:prstGeom prst="rect">
             <a:avLst/>
@@ -5837,7 +6107,7 @@
         <p:spPr>
           <a:xfrm>
             <a:off x="640080" y="1234440"/>
-            <a:ext cx="8046720" cy="3657600"/>
+            <a:ext cx="5029200" cy="3657600"/>
           </a:xfrm>
           <a:prstGeom prst="rect">
             <a:avLst/>
@@ -5862,10 +6132,7 @@
                 </a:solidFill>
                 <a:latin typeface="Calibri"/>
               </a:rPr>
-              <a:t>  Deep learning detects cancers earlier than human radiologists</a:t>
-            </a:r>
-            <a:r>
-              <a:t/>
+              <a:t>  Global shortage of 10M health workers by 2030</a:t>
             </a:r>
           </a:p>
           <a:p>
@@ -5881,10 +6148,7 @@
                 </a:solidFill>
                 <a:latin typeface="Calibri"/>
               </a:rPr>
-              <a:t>  Genomic AI tailors drug therapies to individual patients</a:t>
-            </a:r>
-            <a:r>
-              <a:t/>
+              <a:t>  Diagnostic errors affect 12M Americans annually</a:t>
             </a:r>
           </a:p>
           <a:p>
@@ -5900,10 +6164,7 @@
                 </a:solidFill>
                 <a:latin typeface="Calibri"/>
               </a:rPr>
-              <a:t>  Predictive models identify at-risk populations before symptoms appear</a:t>
-            </a:r>
-            <a:r>
-              <a:t/>
+              <a:t>  Clinician burnout rates exceed 50% post-pandemic</a:t>
             </a:r>
           </a:p>
           <a:p>
@@ -5919,14 +6180,35 @@
                 </a:solidFill>
                 <a:latin typeface="Calibri"/>
               </a:rPr>
-              <a:t>  NLP extracts insights from millions of unstructured clinical notes</a:t>
-            </a:r>
-            <a:r>
-              <a:t/>
-            </a:r>
-          </a:p>
-        </p:txBody>
-      </p:sp>
+              <a:t>  Per-capita costs rising 4-6% year over year</a:t>
+            </a:r>
+          </a:p>
+        </p:txBody>
+      </p:sp>
+      <p:pic>
+        <p:nvPicPr>
+          <p:cNvPr id="6" name="Picture 5" descr="image.jpg"/>
+          <p:cNvPicPr>
+            <a:picLocks noChangeAspect="1"/>
+          </p:cNvPicPr>
+          <p:nvPr/>
+        </p:nvPicPr>
+        <p:blipFill>
+          <a:blip r:embed="rId2"/>
+          <a:stretch>
+            <a:fillRect/>
+          </a:stretch>
+        </p:blipFill>
+        <p:spPr>
+          <a:xfrm>
+            <a:off x="5852160" y="1097280"/>
+            <a:ext cx="2926080" cy="3474720"/>
+          </a:xfrm>
+          <a:prstGeom prst="rect">
+            <a:avLst/>
+          </a:prstGeom>
+        </p:spPr>
+      </p:pic>
     </p:spTree>
   </p:cSld>
   <p:clrMapOvr>
@@ -5955,49 +6237,14 @@
       <p:grpSpPr/>
       <p:sp>
         <p:nvSpPr>
-          <p:cNvPr id="2" name="TextBox 1"/>
-          <p:cNvSpPr txBox="1"/>
-          <p:nvPr/>
-        </p:nvSpPr>
-        <p:spPr>
-          <a:xfrm>
-            <a:off x="640080" y="228600"/>
-            <a:ext cx="7863840" cy="640080"/>
-          </a:xfrm>
-          <a:prstGeom prst="rect">
-            <a:avLst/>
-          </a:prstGeom>
-          <a:noFill/>
-        </p:spPr>
-        <p:txBody>
-          <a:bodyPr wrap="square">
-            <a:spAutoFit/>
-          </a:bodyPr>
-          <a:lstStyle/>
-          <a:p>
-            <a:pPr algn="ctr"/>
-            <a:r>
-              <a:rPr sz="2200" b="1">
-                <a:solidFill>
-                  <a:srgbClr val="55657A"/>
-                </a:solidFill>
-                <a:latin typeface="Calibri"/>
-              </a:rPr>
-              <a:t>Diagnostic Impact in Practice</a:t>
-            </a:r>
-          </a:p>
-        </p:txBody>
-      </p:sp>
-      <p:sp>
-        <p:nvSpPr>
-          <p:cNvPr id="3" name="Rectangle 2"/>
+          <p:cNvPr id="2" name="Rectangle 1"/>
           <p:cNvSpPr/>
           <p:nvPr/>
         </p:nvSpPr>
         <p:spPr>
           <a:xfrm>
-            <a:off x="3657600" y="960120"/>
-            <a:ext cx="1828800" cy="36576"/>
+            <a:off x="457200" y="1005840"/>
+            <a:ext cx="54864" cy="502920"/>
           </a:xfrm>
           <a:prstGeom prst="rect">
             <a:avLst/>
@@ -6033,14 +6280,14 @@
       </p:sp>
       <p:sp>
         <p:nvSpPr>
-          <p:cNvPr id="4" name="TextBox 3"/>
+          <p:cNvPr id="3" name="TextBox 2"/>
           <p:cNvSpPr txBox="1"/>
           <p:nvPr/>
         </p:nvSpPr>
         <p:spPr>
           <a:xfrm>
-            <a:off x="457200" y="1097280"/>
-            <a:ext cx="8229600" cy="2194560"/>
+            <a:off x="640080" y="256032"/>
+            <a:ext cx="5029200" cy="822960"/>
           </a:xfrm>
           <a:prstGeom prst="rect">
             <a:avLst/>
@@ -6053,54 +6300,173 @@
           </a:bodyPr>
           <a:lstStyle/>
           <a:p>
-            <a:pPr algn="ctr"/>
-            <a:r>
-              <a:rPr sz="8000" b="1">
-                <a:solidFill>
-                  <a:srgbClr val="B88600"/>
-                </a:solidFill>
-                <a:latin typeface="Calibri"/>
-              </a:rPr>
-              <a:t>94.5%</a:t>
-            </a:r>
-          </a:p>
-        </p:txBody>
-      </p:sp>
-      <p:sp>
-        <p:nvSpPr>
-          <p:cNvPr id="5" name="TextBox 4"/>
-          <p:cNvSpPr txBox="1"/>
-          <p:nvPr/>
-        </p:nvSpPr>
-        <p:spPr>
-          <a:xfrm>
-            <a:off x="457200" y="3383280"/>
-            <a:ext cx="8229600" cy="731520"/>
-          </a:xfrm>
-          <a:prstGeom prst="rect">
-            <a:avLst/>
-          </a:prstGeom>
-          <a:noFill/>
-        </p:spPr>
-        <p:txBody>
-          <a:bodyPr wrap="square">
-            <a:spAutoFit/>
-          </a:bodyPr>
-          <a:lstStyle/>
-          <a:p>
-            <a:pPr algn="ctr"/>
-            <a:r>
-              <a:rPr sz="2000" b="0">
+            <a:pPr algn="l"/>
+            <a:r>
+              <a:rPr sz="2800" b="1">
                 <a:solidFill>
                   <a:srgbClr val="0D1B2A"/>
                 </a:solidFill>
                 <a:latin typeface="Calibri"/>
               </a:rPr>
-              <a:t>Accuracy of AI in detecting breast cancer in screening mammograms — surpassing average radiologist performance</a:t>
-            </a:r>
-          </a:p>
-        </p:txBody>
-      </p:sp>
+              <a:t>AI-Powered Clinical Breakthroughs</a:t>
+            </a:r>
+          </a:p>
+        </p:txBody>
+      </p:sp>
+      <p:sp>
+        <p:nvSpPr>
+          <p:cNvPr id="4" name="Rectangle 3"/>
+          <p:cNvSpPr/>
+          <p:nvPr/>
+        </p:nvSpPr>
+        <p:spPr>
+          <a:xfrm>
+            <a:off x="457200" y="1024128"/>
+            <a:ext cx="5212080" cy="18288"/>
+          </a:xfrm>
+          <a:prstGeom prst="rect">
+            <a:avLst/>
+          </a:prstGeom>
+          <a:solidFill>
+            <a:srgbClr val="E2DED5"/>
+          </a:solidFill>
+          <a:ln>
+            <a:noFill/>
+          </a:ln>
+        </p:spPr>
+        <p:style>
+          <a:lnRef idx="1">
+            <a:schemeClr val="accent1"/>
+          </a:lnRef>
+          <a:fillRef idx="3">
+            <a:schemeClr val="accent1"/>
+          </a:fillRef>
+          <a:effectRef idx="2">
+            <a:schemeClr val="accent1"/>
+          </a:effectRef>
+          <a:fontRef idx="minor">
+            <a:schemeClr val="lt1"/>
+          </a:fontRef>
+        </p:style>
+        <p:txBody>
+          <a:bodyPr rtlCol="0" anchor="ctr"/>
+          <a:lstStyle/>
+          <a:p>
+            <a:pPr algn="ctr"/>
+          </a:p>
+        </p:txBody>
+      </p:sp>
+      <p:sp>
+        <p:nvSpPr>
+          <p:cNvPr id="5" name="TextBox 4"/>
+          <p:cNvSpPr txBox="1"/>
+          <p:nvPr/>
+        </p:nvSpPr>
+        <p:spPr>
+          <a:xfrm>
+            <a:off x="640080" y="1234440"/>
+            <a:ext cx="5029200" cy="3657600"/>
+          </a:xfrm>
+          <a:prstGeom prst="rect">
+            <a:avLst/>
+          </a:prstGeom>
+          <a:noFill/>
+        </p:spPr>
+        <p:txBody>
+          <a:bodyPr wrap="square">
+            <a:spAutoFit/>
+          </a:bodyPr>
+          <a:lstStyle/>
+          <a:p>
+            <a:pPr>
+              <a:spcBef>
+                <a:spcPts val="1000"/>
+              </a:spcBef>
+            </a:pPr>
+            <a:r>
+              <a:rPr sz="1900">
+                <a:solidFill>
+                  <a:srgbClr val="0D1B2A"/>
+                </a:solidFill>
+                <a:latin typeface="Calibri"/>
+              </a:rPr>
+              <a:t>  Radiology AI detects cancers 20% earlier than humans alone</a:t>
+            </a:r>
+          </a:p>
+          <a:p>
+            <a:pPr>
+              <a:spcBef>
+                <a:spcPts val="1000"/>
+              </a:spcBef>
+            </a:pPr>
+            <a:r>
+              <a:rPr sz="1900">
+                <a:solidFill>
+                  <a:srgbClr val="0D1B2A"/>
+                </a:solidFill>
+                <a:latin typeface="Calibri"/>
+              </a:rPr>
+              <a:t>  LLMs accelerate drug discovery timelines by 40-60%</a:t>
+            </a:r>
+          </a:p>
+          <a:p>
+            <a:pPr>
+              <a:spcBef>
+                <a:spcPts val="1000"/>
+              </a:spcBef>
+            </a:pPr>
+            <a:r>
+              <a:rPr sz="1900">
+                <a:solidFill>
+                  <a:srgbClr val="0D1B2A"/>
+                </a:solidFill>
+                <a:latin typeface="Calibri"/>
+              </a:rPr>
+              <a:t>  Predictive models reduce hospital readmissions by 25%</a:t>
+            </a:r>
+          </a:p>
+          <a:p>
+            <a:pPr>
+              <a:spcBef>
+                <a:spcPts val="1000"/>
+              </a:spcBef>
+            </a:pPr>
+            <a:r>
+              <a:rPr sz="1900">
+                <a:solidFill>
+                  <a:srgbClr val="0D1B2A"/>
+                </a:solidFill>
+                <a:latin typeface="Calibri"/>
+              </a:rPr>
+              <a:t>  Genomic AI enables truly personalized treatment plans</a:t>
+            </a:r>
+          </a:p>
+        </p:txBody>
+      </p:sp>
+      <p:pic>
+        <p:nvPicPr>
+          <p:cNvPr id="6" name="Picture 5" descr="image.jpg"/>
+          <p:cNvPicPr>
+            <a:picLocks noChangeAspect="1"/>
+          </p:cNvPicPr>
+          <p:nvPr/>
+        </p:nvPicPr>
+        <p:blipFill>
+          <a:blip r:embed="rId2"/>
+          <a:stretch>
+            <a:fillRect/>
+          </a:stretch>
+        </p:blipFill>
+        <p:spPr>
+          <a:xfrm>
+            <a:off x="5852160" y="1097280"/>
+            <a:ext cx="2926080" cy="3474720"/>
+          </a:xfrm>
+          <a:prstGeom prst="rect">
+            <a:avLst/>
+          </a:prstGeom>
+        </p:spPr>
+      </p:pic>
     </p:spTree>
   </p:cSld>
   <p:clrMapOvr>
@@ -6110,6 +6476,180 @@
 </file>
 
 <file path=ppt/slides/slide7.xml><?xml version="1.0" encoding="utf-8"?>
+<p:sld xmlns:a="http://schemas.openxmlformats.org/drawingml/2006/main" xmlns:p="http://schemas.openxmlformats.org/presentationml/2006/main" xmlns:r="http://schemas.openxmlformats.org/officeDocument/2006/relationships">
+  <p:cSld>
+    <p:bg>
+      <p:bgPr>
+        <a:solidFill>
+          <a:srgbClr val="F5F4F0"/>
+        </a:solidFill>
+        <a:effectLst/>
+      </p:bgPr>
+    </p:bg>
+    <p:spTree>
+      <p:nvGrpSpPr>
+        <p:cNvPr id="1" name=""/>
+        <p:cNvGrpSpPr/>
+        <p:nvPr/>
+      </p:nvGrpSpPr>
+      <p:grpSpPr/>
+      <p:sp>
+        <p:nvSpPr>
+          <p:cNvPr id="2" name="TextBox 1"/>
+          <p:cNvSpPr txBox="1"/>
+          <p:nvPr/>
+        </p:nvSpPr>
+        <p:spPr>
+          <a:xfrm>
+            <a:off x="365760" y="91440"/>
+            <a:ext cx="1371600" cy="1097280"/>
+          </a:xfrm>
+          <a:prstGeom prst="rect">
+            <a:avLst/>
+          </a:prstGeom>
+          <a:noFill/>
+        </p:spPr>
+        <p:txBody>
+          <a:bodyPr wrap="square">
+            <a:spAutoFit/>
+          </a:bodyPr>
+          <a:lstStyle/>
+          <a:p>
+            <a:pPr algn="l"/>
+            <a:r>
+              <a:rPr sz="7200" b="1">
+                <a:solidFill>
+                  <a:srgbClr val="B88600"/>
+                </a:solidFill>
+                <a:latin typeface="Calibri"/>
+              </a:rPr>
+              <a:t>“</a:t>
+            </a:r>
+          </a:p>
+        </p:txBody>
+      </p:sp>
+      <p:sp>
+        <p:nvSpPr>
+          <p:cNvPr id="3" name="TextBox 2"/>
+          <p:cNvSpPr txBox="1"/>
+          <p:nvPr/>
+        </p:nvSpPr>
+        <p:spPr>
+          <a:xfrm>
+            <a:off x="640080" y="914400"/>
+            <a:ext cx="7863840" cy="2560320"/>
+          </a:xfrm>
+          <a:prstGeom prst="rect">
+            <a:avLst/>
+          </a:prstGeom>
+          <a:noFill/>
+        </p:spPr>
+        <p:txBody>
+          <a:bodyPr wrap="square">
+            <a:spAutoFit/>
+          </a:bodyPr>
+          <a:lstStyle/>
+          <a:p>
+            <a:pPr algn="l"/>
+            <a:r>
+              <a:rPr sz="2200" b="0">
+                <a:solidFill>
+                  <a:srgbClr val="0D1B2A"/>
+                </a:solidFill>
+                <a:latin typeface="Calibri"/>
+              </a:rPr>
+              <a:t>The greatest opportunity for AI in healthcare is not replacing doctors — it is giving them superhuman tools to save more lives.</a:t>
+            </a:r>
+          </a:p>
+        </p:txBody>
+      </p:sp>
+      <p:sp>
+        <p:nvSpPr>
+          <p:cNvPr id="4" name="TextBox 3"/>
+          <p:cNvSpPr txBox="1"/>
+          <p:nvPr/>
+        </p:nvSpPr>
+        <p:spPr>
+          <a:xfrm>
+            <a:off x="640080" y="3657600"/>
+            <a:ext cx="7863840" cy="457200"/>
+          </a:xfrm>
+          <a:prstGeom prst="rect">
+            <a:avLst/>
+          </a:prstGeom>
+          <a:noFill/>
+        </p:spPr>
+        <p:txBody>
+          <a:bodyPr wrap="square">
+            <a:spAutoFit/>
+          </a:bodyPr>
+          <a:lstStyle/>
+          <a:p>
+            <a:pPr algn="l"/>
+            <a:r>
+              <a:rPr sz="1600" b="0">
+                <a:solidFill>
+                  <a:srgbClr val="55657A"/>
+                </a:solidFill>
+                <a:latin typeface="Calibri"/>
+              </a:rPr>
+              <a:t>— Eric Topol, MD — Author of Deep Medicine</a:t>
+            </a:r>
+          </a:p>
+        </p:txBody>
+      </p:sp>
+      <p:sp>
+        <p:nvSpPr>
+          <p:cNvPr id="5" name="Rectangle 4"/>
+          <p:cNvSpPr/>
+          <p:nvPr/>
+        </p:nvSpPr>
+        <p:spPr>
+          <a:xfrm>
+            <a:off x="640080" y="4297680"/>
+            <a:ext cx="1828800" cy="36576"/>
+          </a:xfrm>
+          <a:prstGeom prst="rect">
+            <a:avLst/>
+          </a:prstGeom>
+          <a:solidFill>
+            <a:srgbClr val="B88600"/>
+          </a:solidFill>
+          <a:ln>
+            <a:noFill/>
+          </a:ln>
+        </p:spPr>
+        <p:style>
+          <a:lnRef idx="1">
+            <a:schemeClr val="accent1"/>
+          </a:lnRef>
+          <a:fillRef idx="3">
+            <a:schemeClr val="accent1"/>
+          </a:fillRef>
+          <a:effectRef idx="2">
+            <a:schemeClr val="accent1"/>
+          </a:effectRef>
+          <a:fontRef idx="minor">
+            <a:schemeClr val="lt1"/>
+          </a:fontRef>
+        </p:style>
+        <p:txBody>
+          <a:bodyPr rtlCol="0" anchor="ctr"/>
+          <a:lstStyle/>
+          <a:p>
+            <a:pPr algn="ctr"/>
+          </a:p>
+        </p:txBody>
+      </p:sp>
+    </p:spTree>
+  </p:cSld>
+  <p:clrMapOvr>
+    <a:masterClrMapping/>
+  </p:clrMapOvr>
+</p:sld>
+</file>
+
+<file path=ppt/slides/slide8.xml><?xml version="1.0" encoding="utf-8"?>
 <p:sld xmlns:a="http://schemas.openxmlformats.org/drawingml/2006/main" xmlns:p="http://schemas.openxmlformats.org/presentationml/2006/main" xmlns:r="http://schemas.openxmlformats.org/officeDocument/2006/relationships">
   <p:cSld>
     <p:bg>
@@ -6157,253 +6697,7 @@
                 </a:solidFill>
                 <a:latin typeface="Calibri"/>
               </a:rPr>
-              <a:t>Section 2: Operational Transformation</a:t>
-            </a:r>
-          </a:p>
-        </p:txBody>
-      </p:sp>
-    </p:spTree>
-  </p:cSld>
-  <p:clrMapOvr>
-    <a:masterClrMapping/>
-  </p:clrMapOvr>
-</p:sld>
-</file>
-
-<file path=ppt/slides/slide8.xml><?xml version="1.0" encoding="utf-8"?>
-<p:sld xmlns:a="http://schemas.openxmlformats.org/drawingml/2006/main" xmlns:p="http://schemas.openxmlformats.org/presentationml/2006/main" xmlns:r="http://schemas.openxmlformats.org/officeDocument/2006/relationships">
-  <p:cSld>
-    <p:bg>
-      <p:bgPr>
-        <a:solidFill>
-          <a:srgbClr val="F5F4F0"/>
-        </a:solidFill>
-        <a:effectLst/>
-      </p:bgPr>
-    </p:bg>
-    <p:spTree>
-      <p:nvGrpSpPr>
-        <p:cNvPr id="1" name=""/>
-        <p:cNvGrpSpPr/>
-        <p:nvPr/>
-      </p:nvGrpSpPr>
-      <p:grpSpPr/>
-      <p:sp>
-        <p:nvSpPr>
-          <p:cNvPr id="2" name="Rectangle 1"/>
-          <p:cNvSpPr/>
-          <p:nvPr/>
-        </p:nvSpPr>
-        <p:spPr>
-          <a:xfrm>
-            <a:off x="457200" y="1005840"/>
-            <a:ext cx="54864" cy="502920"/>
-          </a:xfrm>
-          <a:prstGeom prst="rect">
-            <a:avLst/>
-          </a:prstGeom>
-          <a:solidFill>
-            <a:srgbClr val="B88600"/>
-          </a:solidFill>
-          <a:ln>
-            <a:noFill/>
-          </a:ln>
-        </p:spPr>
-        <p:style>
-          <a:lnRef idx="1">
-            <a:schemeClr val="accent1"/>
-          </a:lnRef>
-          <a:fillRef idx="3">
-            <a:schemeClr val="accent1"/>
-          </a:fillRef>
-          <a:effectRef idx="2">
-            <a:schemeClr val="accent1"/>
-          </a:effectRef>
-          <a:fontRef idx="minor">
-            <a:schemeClr val="lt1"/>
-          </a:fontRef>
-        </p:style>
-        <p:txBody>
-          <a:bodyPr rtlCol="0" anchor="ctr"/>
-          <a:lstStyle/>
-          <a:p>
-            <a:pPr algn="ctr"/>
-          </a:p>
-        </p:txBody>
-      </p:sp>
-      <p:sp>
-        <p:nvSpPr>
-          <p:cNvPr id="3" name="TextBox 2"/>
-          <p:cNvSpPr txBox="1"/>
-          <p:nvPr/>
-        </p:nvSpPr>
-        <p:spPr>
-          <a:xfrm>
-            <a:off x="640080" y="256032"/>
-            <a:ext cx="8046720" cy="822960"/>
-          </a:xfrm>
-          <a:prstGeom prst="rect">
-            <a:avLst/>
-          </a:prstGeom>
-          <a:noFill/>
-        </p:spPr>
-        <p:txBody>
-          <a:bodyPr wrap="square">
-            <a:spAutoFit/>
-          </a:bodyPr>
-          <a:lstStyle/>
-          <a:p>
-            <a:pPr algn="l"/>
-            <a:r>
-              <a:rPr sz="2800" b="1">
-                <a:solidFill>
-                  <a:srgbClr val="0D1B2A"/>
-                </a:solidFill>
-                <a:latin typeface="Calibri"/>
-              </a:rPr>
-              <a:t>Unlocking Efficiency Across the Enterprise</a:t>
-            </a:r>
-          </a:p>
-        </p:txBody>
-      </p:sp>
-      <p:sp>
-        <p:nvSpPr>
-          <p:cNvPr id="4" name="Rectangle 3"/>
-          <p:cNvSpPr/>
-          <p:nvPr/>
-        </p:nvSpPr>
-        <p:spPr>
-          <a:xfrm>
-            <a:off x="457200" y="1024128"/>
-            <a:ext cx="8229600" cy="18288"/>
-          </a:xfrm>
-          <a:prstGeom prst="rect">
-            <a:avLst/>
-          </a:prstGeom>
-          <a:solidFill>
-            <a:srgbClr val="E2DED5"/>
-          </a:solidFill>
-          <a:ln>
-            <a:noFill/>
-          </a:ln>
-        </p:spPr>
-        <p:style>
-          <a:lnRef idx="1">
-            <a:schemeClr val="accent1"/>
-          </a:lnRef>
-          <a:fillRef idx="3">
-            <a:schemeClr val="accent1"/>
-          </a:fillRef>
-          <a:effectRef idx="2">
-            <a:schemeClr val="accent1"/>
-          </a:effectRef>
-          <a:fontRef idx="minor">
-            <a:schemeClr val="lt1"/>
-          </a:fontRef>
-        </p:style>
-        <p:txBody>
-          <a:bodyPr rtlCol="0" anchor="ctr"/>
-          <a:lstStyle/>
-          <a:p>
-            <a:pPr algn="ctr"/>
-          </a:p>
-        </p:txBody>
-      </p:sp>
-      <p:sp>
-        <p:nvSpPr>
-          <p:cNvPr id="5" name="TextBox 4"/>
-          <p:cNvSpPr txBox="1"/>
-          <p:nvPr/>
-        </p:nvSpPr>
-        <p:spPr>
-          <a:xfrm>
-            <a:off x="640080" y="1234440"/>
-            <a:ext cx="8046720" cy="3657600"/>
-          </a:xfrm>
-          <a:prstGeom prst="rect">
-            <a:avLst/>
-          </a:prstGeom>
-          <a:noFill/>
-        </p:spPr>
-        <p:txBody>
-          <a:bodyPr wrap="square">
-            <a:spAutoFit/>
-          </a:bodyPr>
-          <a:lstStyle/>
-          <a:p>
-            <a:pPr>
-              <a:spcBef>
-                <a:spcPts val="1000"/>
-              </a:spcBef>
-            </a:pPr>
-            <a:r>
-              <a:rPr sz="1900">
-                <a:solidFill>
-                  <a:srgbClr val="0D1B2A"/>
-                </a:solidFill>
-                <a:latin typeface="Calibri"/>
-              </a:rPr>
-              <a:t>  Automated scheduling reduces patient wait times by 30%</a:t>
-            </a:r>
-            <a:r>
-              <a:t/>
-            </a:r>
-          </a:p>
-          <a:p>
-            <a:pPr>
-              <a:spcBef>
-                <a:spcPts val="1000"/>
-              </a:spcBef>
-            </a:pPr>
-            <a:r>
-              <a:rPr sz="1900">
-                <a:solidFill>
-                  <a:srgbClr val="0D1B2A"/>
-                </a:solidFill>
-                <a:latin typeface="Calibri"/>
-              </a:rPr>
-              <a:t>  AI-driven coding accelerates revenue cycle management</a:t>
-            </a:r>
-            <a:r>
-              <a:t/>
-            </a:r>
-          </a:p>
-          <a:p>
-            <a:pPr>
-              <a:spcBef>
-                <a:spcPts val="1000"/>
-              </a:spcBef>
-            </a:pPr>
-            <a:r>
-              <a:rPr sz="1900">
-                <a:solidFill>
-                  <a:srgbClr val="0D1B2A"/>
-                </a:solidFill>
-                <a:latin typeface="Calibri"/>
-              </a:rPr>
-              <a:t>  Virtual nursing assistants handle 60% of routine inquiries</a:t>
-            </a:r>
-            <a:r>
-              <a:t/>
-            </a:r>
-          </a:p>
-          <a:p>
-            <a:pPr>
-              <a:spcBef>
-                <a:spcPts val="1000"/>
-              </a:spcBef>
-            </a:pPr>
-            <a:r>
-              <a:rPr sz="1900">
-                <a:solidFill>
-                  <a:srgbClr val="0D1B2A"/>
-                </a:solidFill>
-                <a:latin typeface="Calibri"/>
-              </a:rPr>
-              <a:t>  Supply chain optimization cuts pharmaceutical waste significantly</a:t>
-            </a:r>
-            <a:r>
-              <a:t/>
+              <a:t>Operational Transformation</a:t>
             </a:r>
           </a:p>
         </p:txBody>
@@ -6486,7 +6780,7 @@
         <p:spPr>
           <a:xfrm>
             <a:off x="640080" y="256032"/>
-            <a:ext cx="8046720" cy="822960"/>
+            <a:ext cx="5029200" cy="822960"/>
           </a:xfrm>
           <a:prstGeom prst="rect">
             <a:avLst/>
@@ -6507,7 +6801,7 @@
                 </a:solidFill>
                 <a:latin typeface="Calibri"/>
               </a:rPr>
-              <a:t>Workforce Augmentation, Not Replacement</a:t>
+              <a:t>AI Across the Healthcare Value Chain</a:t>
             </a:r>
           </a:p>
         </p:txBody>
@@ -6521,7 +6815,7 @@
         <p:spPr>
           <a:xfrm>
             <a:off x="457200" y="1024128"/>
-            <a:ext cx="8229600" cy="18288"/>
+            <a:ext cx="5212080" cy="18288"/>
           </a:xfrm>
           <a:prstGeom prst="rect">
             <a:avLst/>
@@ -6564,7 +6858,7 @@
         <p:spPr>
           <a:xfrm>
             <a:off x="640080" y="1234440"/>
-            <a:ext cx="8046720" cy="3657600"/>
+            <a:ext cx="5029200" cy="3657600"/>
           </a:xfrm>
           <a:prstGeom prst="rect">
             <a:avLst/>
@@ -6589,10 +6883,7 @@
                 </a:solidFill>
                 <a:latin typeface="Calibri"/>
               </a:rPr>
-              <a:t>  AI handles administrative burden so clinicians treat patients</a:t>
-            </a:r>
-            <a:r>
-              <a:t/>
+              <a:t>  Revenue cycle automation reduces claim denials by 30%</a:t>
             </a:r>
           </a:p>
           <a:p>
@@ -6608,10 +6899,7 @@
                 </a:solidFill>
                 <a:latin typeface="Calibri"/>
               </a:rPr>
-              <a:t>  Burnout reduction through intelligent workload distribution</a:t>
-            </a:r>
-            <a:r>
-              <a:t/>
+              <a:t>  NLP streamlines clinical documentation and coding</a:t>
             </a:r>
           </a:p>
           <a:p>
@@ -6627,10 +6915,7 @@
                 </a:solidFill>
                 <a:latin typeface="Calibri"/>
               </a:rPr>
-              <a:t>  Upskilling programs create new AI-literate clinical roles</a:t>
-            </a:r>
-            <a:r>
-              <a:t/>
+              <a:t>  Supply chain AI cuts inventory waste by 20-35%</a:t>
             </a:r>
           </a:p>
           <a:p>
@@ -6646,14 +6931,35 @@
                 </a:solidFill>
                 <a:latin typeface="Calibri"/>
               </a:rPr>
-              <a:t>  Human-AI collaboration outperforms either working alone</a:t>
-            </a:r>
-            <a:r>
-              <a:t/>
-            </a:r>
-          </a:p>
-        </p:txBody>
-      </p:sp>
+              <a:t>  Virtual triage deflects 40% of low-acuity ED visits</a:t>
+            </a:r>
+          </a:p>
+        </p:txBody>
+      </p:sp>
+      <p:pic>
+        <p:nvPicPr>
+          <p:cNvPr id="6" name="Picture 5" descr="image.jpg"/>
+          <p:cNvPicPr>
+            <a:picLocks noChangeAspect="1"/>
+          </p:cNvPicPr>
+          <p:nvPr/>
+        </p:nvPicPr>
+        <p:blipFill>
+          <a:blip r:embed="rId2"/>
+          <a:stretch>
+            <a:fillRect/>
+          </a:stretch>
+        </p:blipFill>
+        <p:spPr>
+          <a:xfrm>
+            <a:off x="5852160" y="1097280"/>
+            <a:ext cx="2926080" cy="3474720"/>
+          </a:xfrm>
+          <a:prstGeom prst="rect">
+            <a:avLst/>
+          </a:prstGeom>
+        </p:spPr>
+      </p:pic>
     </p:spTree>
   </p:cSld>
   <p:clrMapOvr>

</xml_diff>